<commit_message>
Sunum artefaktlari: 5 slaytlik juri sunumu (html/pdf/pptx) + 15'lik arsiv
Eski 15 slaytlik surum docs/archive/ altinda korunuyor (HARD RULE 3);
ekran kareleri ve uretim betikleri yerelde uretilir, depoya girmez.

Co-Authored-By: Claude Fable 5 <noreply@anthropic.com>
</commit_message>
<xml_diff>
--- a/app/docs/sunum/anatolia-ai-sunum.pptx
+++ b/app/docs/sunum/anatolia-ai-sunum.pptx
@@ -10,16 +10,6 @@
     <p:sldId id="258" r:id="rId9"/>
     <p:sldId id="259" r:id="rId10"/>
     <p:sldId id="260" r:id="rId11"/>
-    <p:sldId id="261" r:id="rId12"/>
-    <p:sldId id="262" r:id="rId13"/>
-    <p:sldId id="263" r:id="rId14"/>
-    <p:sldId id="264" r:id="rId15"/>
-    <p:sldId id="265" r:id="rId16"/>
-    <p:sldId id="266" r:id="rId17"/>
-    <p:sldId id="267" r:id="rId18"/>
-    <p:sldId id="268" r:id="rId19"/>
-    <p:sldId id="269" r:id="rId20"/>
-    <p:sldId id="270" r:id="rId21"/>
   </p:sldIdLst>
   <p:sldSz cx="18288000" cy="10287000" type="screen4x3"/>
   <p:notesSz cx="6858000" cy="9144000"/>
@@ -3134,258 +3124,6 @@
 </p:sld>
 </file>
 
-<file path=ppt/slides/slide10.xml><?xml version="1.0" encoding="utf-8"?>
-<p:sld xmlns:a="http://schemas.openxmlformats.org/drawingml/2006/main" xmlns:p="http://schemas.openxmlformats.org/presentationml/2006/main" xmlns:r="http://schemas.openxmlformats.org/officeDocument/2006/relationships">
-  <p:cSld>
-    <p:spTree>
-      <p:nvGrpSpPr>
-        <p:cNvPr id="1" name=""/>
-        <p:cNvGrpSpPr/>
-        <p:nvPr/>
-      </p:nvGrpSpPr>
-      <p:grpSpPr/>
-      <p:pic>
-        <p:nvPicPr>
-          <p:cNvPr id="2" name="Picture 1" descr="slayt-10.png"/>
-          <p:cNvPicPr>
-            <a:picLocks noChangeAspect="1"/>
-          </p:cNvPicPr>
-          <p:nvPr/>
-        </p:nvPicPr>
-        <p:blipFill>
-          <a:blip r:embed="rId2"/>
-          <a:stretch>
-            <a:fillRect/>
-          </a:stretch>
-        </p:blipFill>
-        <p:spPr>
-          <a:xfrm>
-            <a:off x="0" y="0"/>
-            <a:ext cx="18288000" cy="10287000"/>
-          </a:xfrm>
-          <a:prstGeom prst="rect">
-            <a:avLst/>
-          </a:prstGeom>
-        </p:spPr>
-      </p:pic>
-    </p:spTree>
-  </p:cSld>
-  <p:clrMapOvr>
-    <a:masterClrMapping/>
-  </p:clrMapOvr>
-</p:sld>
-</file>
-
-<file path=ppt/slides/slide11.xml><?xml version="1.0" encoding="utf-8"?>
-<p:sld xmlns:a="http://schemas.openxmlformats.org/drawingml/2006/main" xmlns:p="http://schemas.openxmlformats.org/presentationml/2006/main" xmlns:r="http://schemas.openxmlformats.org/officeDocument/2006/relationships">
-  <p:cSld>
-    <p:spTree>
-      <p:nvGrpSpPr>
-        <p:cNvPr id="1" name=""/>
-        <p:cNvGrpSpPr/>
-        <p:nvPr/>
-      </p:nvGrpSpPr>
-      <p:grpSpPr/>
-      <p:pic>
-        <p:nvPicPr>
-          <p:cNvPr id="2" name="Picture 1" descr="slayt-11.png"/>
-          <p:cNvPicPr>
-            <a:picLocks noChangeAspect="1"/>
-          </p:cNvPicPr>
-          <p:nvPr/>
-        </p:nvPicPr>
-        <p:blipFill>
-          <a:blip r:embed="rId2"/>
-          <a:stretch>
-            <a:fillRect/>
-          </a:stretch>
-        </p:blipFill>
-        <p:spPr>
-          <a:xfrm>
-            <a:off x="0" y="0"/>
-            <a:ext cx="18288000" cy="10287000"/>
-          </a:xfrm>
-          <a:prstGeom prst="rect">
-            <a:avLst/>
-          </a:prstGeom>
-        </p:spPr>
-      </p:pic>
-    </p:spTree>
-  </p:cSld>
-  <p:clrMapOvr>
-    <a:masterClrMapping/>
-  </p:clrMapOvr>
-</p:sld>
-</file>
-
-<file path=ppt/slides/slide12.xml><?xml version="1.0" encoding="utf-8"?>
-<p:sld xmlns:a="http://schemas.openxmlformats.org/drawingml/2006/main" xmlns:p="http://schemas.openxmlformats.org/presentationml/2006/main" xmlns:r="http://schemas.openxmlformats.org/officeDocument/2006/relationships">
-  <p:cSld>
-    <p:spTree>
-      <p:nvGrpSpPr>
-        <p:cNvPr id="1" name=""/>
-        <p:cNvGrpSpPr/>
-        <p:nvPr/>
-      </p:nvGrpSpPr>
-      <p:grpSpPr/>
-      <p:pic>
-        <p:nvPicPr>
-          <p:cNvPr id="2" name="Picture 1" descr="slayt-12.png"/>
-          <p:cNvPicPr>
-            <a:picLocks noChangeAspect="1"/>
-          </p:cNvPicPr>
-          <p:nvPr/>
-        </p:nvPicPr>
-        <p:blipFill>
-          <a:blip r:embed="rId2"/>
-          <a:stretch>
-            <a:fillRect/>
-          </a:stretch>
-        </p:blipFill>
-        <p:spPr>
-          <a:xfrm>
-            <a:off x="0" y="0"/>
-            <a:ext cx="18288000" cy="10287000"/>
-          </a:xfrm>
-          <a:prstGeom prst="rect">
-            <a:avLst/>
-          </a:prstGeom>
-        </p:spPr>
-      </p:pic>
-    </p:spTree>
-  </p:cSld>
-  <p:clrMapOvr>
-    <a:masterClrMapping/>
-  </p:clrMapOvr>
-</p:sld>
-</file>
-
-<file path=ppt/slides/slide13.xml><?xml version="1.0" encoding="utf-8"?>
-<p:sld xmlns:a="http://schemas.openxmlformats.org/drawingml/2006/main" xmlns:p="http://schemas.openxmlformats.org/presentationml/2006/main" xmlns:r="http://schemas.openxmlformats.org/officeDocument/2006/relationships">
-  <p:cSld>
-    <p:spTree>
-      <p:nvGrpSpPr>
-        <p:cNvPr id="1" name=""/>
-        <p:cNvGrpSpPr/>
-        <p:nvPr/>
-      </p:nvGrpSpPr>
-      <p:grpSpPr/>
-      <p:pic>
-        <p:nvPicPr>
-          <p:cNvPr id="2" name="Picture 1" descr="slayt-13.png"/>
-          <p:cNvPicPr>
-            <a:picLocks noChangeAspect="1"/>
-          </p:cNvPicPr>
-          <p:nvPr/>
-        </p:nvPicPr>
-        <p:blipFill>
-          <a:blip r:embed="rId2"/>
-          <a:stretch>
-            <a:fillRect/>
-          </a:stretch>
-        </p:blipFill>
-        <p:spPr>
-          <a:xfrm>
-            <a:off x="0" y="0"/>
-            <a:ext cx="18288000" cy="10287000"/>
-          </a:xfrm>
-          <a:prstGeom prst="rect">
-            <a:avLst/>
-          </a:prstGeom>
-        </p:spPr>
-      </p:pic>
-    </p:spTree>
-  </p:cSld>
-  <p:clrMapOvr>
-    <a:masterClrMapping/>
-  </p:clrMapOvr>
-</p:sld>
-</file>
-
-<file path=ppt/slides/slide14.xml><?xml version="1.0" encoding="utf-8"?>
-<p:sld xmlns:a="http://schemas.openxmlformats.org/drawingml/2006/main" xmlns:p="http://schemas.openxmlformats.org/presentationml/2006/main" xmlns:r="http://schemas.openxmlformats.org/officeDocument/2006/relationships">
-  <p:cSld>
-    <p:spTree>
-      <p:nvGrpSpPr>
-        <p:cNvPr id="1" name=""/>
-        <p:cNvGrpSpPr/>
-        <p:nvPr/>
-      </p:nvGrpSpPr>
-      <p:grpSpPr/>
-      <p:pic>
-        <p:nvPicPr>
-          <p:cNvPr id="2" name="Picture 1" descr="slayt-14.png"/>
-          <p:cNvPicPr>
-            <a:picLocks noChangeAspect="1"/>
-          </p:cNvPicPr>
-          <p:nvPr/>
-        </p:nvPicPr>
-        <p:blipFill>
-          <a:blip r:embed="rId2"/>
-          <a:stretch>
-            <a:fillRect/>
-          </a:stretch>
-        </p:blipFill>
-        <p:spPr>
-          <a:xfrm>
-            <a:off x="0" y="0"/>
-            <a:ext cx="18288000" cy="10287000"/>
-          </a:xfrm>
-          <a:prstGeom prst="rect">
-            <a:avLst/>
-          </a:prstGeom>
-        </p:spPr>
-      </p:pic>
-    </p:spTree>
-  </p:cSld>
-  <p:clrMapOvr>
-    <a:masterClrMapping/>
-  </p:clrMapOvr>
-</p:sld>
-</file>
-
-<file path=ppt/slides/slide15.xml><?xml version="1.0" encoding="utf-8"?>
-<p:sld xmlns:a="http://schemas.openxmlformats.org/drawingml/2006/main" xmlns:p="http://schemas.openxmlformats.org/presentationml/2006/main" xmlns:r="http://schemas.openxmlformats.org/officeDocument/2006/relationships">
-  <p:cSld>
-    <p:spTree>
-      <p:nvGrpSpPr>
-        <p:cNvPr id="1" name=""/>
-        <p:cNvGrpSpPr/>
-        <p:nvPr/>
-      </p:nvGrpSpPr>
-      <p:grpSpPr/>
-      <p:pic>
-        <p:nvPicPr>
-          <p:cNvPr id="2" name="Picture 1" descr="slayt-15.png"/>
-          <p:cNvPicPr>
-            <a:picLocks noChangeAspect="1"/>
-          </p:cNvPicPr>
-          <p:nvPr/>
-        </p:nvPicPr>
-        <p:blipFill>
-          <a:blip r:embed="rId2"/>
-          <a:stretch>
-            <a:fillRect/>
-          </a:stretch>
-        </p:blipFill>
-        <p:spPr>
-          <a:xfrm>
-            <a:off x="0" y="0"/>
-            <a:ext cx="18288000" cy="10287000"/>
-          </a:xfrm>
-          <a:prstGeom prst="rect">
-            <a:avLst/>
-          </a:prstGeom>
-        </p:spPr>
-      </p:pic>
-    </p:spTree>
-  </p:cSld>
-  <p:clrMapOvr>
-    <a:masterClrMapping/>
-  </p:clrMapOvr>
-</p:sld>
-</file>
-
 <file path=ppt/slides/slide2.xml><?xml version="1.0" encoding="utf-8"?>
 <p:sld xmlns:a="http://schemas.openxmlformats.org/drawingml/2006/main" xmlns:p="http://schemas.openxmlformats.org/presentationml/2006/main" xmlns:r="http://schemas.openxmlformats.org/officeDocument/2006/relationships">
   <p:cSld>
@@ -3525,174 +3263,6 @@
       <p:pic>
         <p:nvPicPr>
           <p:cNvPr id="2" name="Picture 1" descr="slayt-05.png"/>
-          <p:cNvPicPr>
-            <a:picLocks noChangeAspect="1"/>
-          </p:cNvPicPr>
-          <p:nvPr/>
-        </p:nvPicPr>
-        <p:blipFill>
-          <a:blip r:embed="rId2"/>
-          <a:stretch>
-            <a:fillRect/>
-          </a:stretch>
-        </p:blipFill>
-        <p:spPr>
-          <a:xfrm>
-            <a:off x="0" y="0"/>
-            <a:ext cx="18288000" cy="10287000"/>
-          </a:xfrm>
-          <a:prstGeom prst="rect">
-            <a:avLst/>
-          </a:prstGeom>
-        </p:spPr>
-      </p:pic>
-    </p:spTree>
-  </p:cSld>
-  <p:clrMapOvr>
-    <a:masterClrMapping/>
-  </p:clrMapOvr>
-</p:sld>
-</file>
-
-<file path=ppt/slides/slide6.xml><?xml version="1.0" encoding="utf-8"?>
-<p:sld xmlns:a="http://schemas.openxmlformats.org/drawingml/2006/main" xmlns:p="http://schemas.openxmlformats.org/presentationml/2006/main" xmlns:r="http://schemas.openxmlformats.org/officeDocument/2006/relationships">
-  <p:cSld>
-    <p:spTree>
-      <p:nvGrpSpPr>
-        <p:cNvPr id="1" name=""/>
-        <p:cNvGrpSpPr/>
-        <p:nvPr/>
-      </p:nvGrpSpPr>
-      <p:grpSpPr/>
-      <p:pic>
-        <p:nvPicPr>
-          <p:cNvPr id="2" name="Picture 1" descr="slayt-06.png"/>
-          <p:cNvPicPr>
-            <a:picLocks noChangeAspect="1"/>
-          </p:cNvPicPr>
-          <p:nvPr/>
-        </p:nvPicPr>
-        <p:blipFill>
-          <a:blip r:embed="rId2"/>
-          <a:stretch>
-            <a:fillRect/>
-          </a:stretch>
-        </p:blipFill>
-        <p:spPr>
-          <a:xfrm>
-            <a:off x="0" y="0"/>
-            <a:ext cx="18288000" cy="10287000"/>
-          </a:xfrm>
-          <a:prstGeom prst="rect">
-            <a:avLst/>
-          </a:prstGeom>
-        </p:spPr>
-      </p:pic>
-    </p:spTree>
-  </p:cSld>
-  <p:clrMapOvr>
-    <a:masterClrMapping/>
-  </p:clrMapOvr>
-</p:sld>
-</file>
-
-<file path=ppt/slides/slide7.xml><?xml version="1.0" encoding="utf-8"?>
-<p:sld xmlns:a="http://schemas.openxmlformats.org/drawingml/2006/main" xmlns:p="http://schemas.openxmlformats.org/presentationml/2006/main" xmlns:r="http://schemas.openxmlformats.org/officeDocument/2006/relationships">
-  <p:cSld>
-    <p:spTree>
-      <p:nvGrpSpPr>
-        <p:cNvPr id="1" name=""/>
-        <p:cNvGrpSpPr/>
-        <p:nvPr/>
-      </p:nvGrpSpPr>
-      <p:grpSpPr/>
-      <p:pic>
-        <p:nvPicPr>
-          <p:cNvPr id="2" name="Picture 1" descr="slayt-07.png"/>
-          <p:cNvPicPr>
-            <a:picLocks noChangeAspect="1"/>
-          </p:cNvPicPr>
-          <p:nvPr/>
-        </p:nvPicPr>
-        <p:blipFill>
-          <a:blip r:embed="rId2"/>
-          <a:stretch>
-            <a:fillRect/>
-          </a:stretch>
-        </p:blipFill>
-        <p:spPr>
-          <a:xfrm>
-            <a:off x="0" y="0"/>
-            <a:ext cx="18288000" cy="10287000"/>
-          </a:xfrm>
-          <a:prstGeom prst="rect">
-            <a:avLst/>
-          </a:prstGeom>
-        </p:spPr>
-      </p:pic>
-    </p:spTree>
-  </p:cSld>
-  <p:clrMapOvr>
-    <a:masterClrMapping/>
-  </p:clrMapOvr>
-</p:sld>
-</file>
-
-<file path=ppt/slides/slide8.xml><?xml version="1.0" encoding="utf-8"?>
-<p:sld xmlns:a="http://schemas.openxmlformats.org/drawingml/2006/main" xmlns:p="http://schemas.openxmlformats.org/presentationml/2006/main" xmlns:r="http://schemas.openxmlformats.org/officeDocument/2006/relationships">
-  <p:cSld>
-    <p:spTree>
-      <p:nvGrpSpPr>
-        <p:cNvPr id="1" name=""/>
-        <p:cNvGrpSpPr/>
-        <p:nvPr/>
-      </p:nvGrpSpPr>
-      <p:grpSpPr/>
-      <p:pic>
-        <p:nvPicPr>
-          <p:cNvPr id="2" name="Picture 1" descr="slayt-08.png"/>
-          <p:cNvPicPr>
-            <a:picLocks noChangeAspect="1"/>
-          </p:cNvPicPr>
-          <p:nvPr/>
-        </p:nvPicPr>
-        <p:blipFill>
-          <a:blip r:embed="rId2"/>
-          <a:stretch>
-            <a:fillRect/>
-          </a:stretch>
-        </p:blipFill>
-        <p:spPr>
-          <a:xfrm>
-            <a:off x="0" y="0"/>
-            <a:ext cx="18288000" cy="10287000"/>
-          </a:xfrm>
-          <a:prstGeom prst="rect">
-            <a:avLst/>
-          </a:prstGeom>
-        </p:spPr>
-      </p:pic>
-    </p:spTree>
-  </p:cSld>
-  <p:clrMapOvr>
-    <a:masterClrMapping/>
-  </p:clrMapOvr>
-</p:sld>
-</file>
-
-<file path=ppt/slides/slide9.xml><?xml version="1.0" encoding="utf-8"?>
-<p:sld xmlns:a="http://schemas.openxmlformats.org/drawingml/2006/main" xmlns:p="http://schemas.openxmlformats.org/presentationml/2006/main" xmlns:r="http://schemas.openxmlformats.org/officeDocument/2006/relationships">
-  <p:cSld>
-    <p:spTree>
-      <p:nvGrpSpPr>
-        <p:cNvPr id="1" name=""/>
-        <p:cNvGrpSpPr/>
-        <p:nvPr/>
-      </p:nvGrpSpPr>
-      <p:grpSpPr/>
-      <p:pic>
-        <p:nvPicPr>
-          <p:cNvPr id="2" name="Picture 1" descr="slayt-09.png"/>
           <p:cNvPicPr>
             <a:picLocks noChangeAspect="1"/>
           </p:cNvPicPr>

</xml_diff>